<commit_message>
new atelier story templates
</commit_message>
<xml_diff>
--- a/atelier/atelier-s01-project-reveal.pptx
+++ b/atelier/atelier-s01-project-reveal.pptx
@@ -3140,14 +3140,14 @@
         </p:nvSpPr>
         <p:spPr>
           <a:xfrm>
-            <a:off x="762000" y="15735300"/>
+            <a:off x="762000" y="15782925"/>
             <a:ext cx="8763000" cy="9525"/>
           </a:xfrm>
           <a:prstGeom prst="rect">
             <a:avLst/>
           </a:prstGeom>
           <a:solidFill>
-            <a:srgbClr val="524F4B"/>
+            <a:srgbClr val="595552"/>
           </a:solidFill>
           <a:ln>
             <a:noFill/>
@@ -3184,14 +3184,14 @@
         </p:nvSpPr>
         <p:spPr>
           <a:xfrm>
-            <a:off x="762000" y="16373475"/>
+            <a:off x="762000" y="16659225"/>
             <a:ext cx="8763000" cy="9525"/>
           </a:xfrm>
           <a:prstGeom prst="rect">
             <a:avLst/>
           </a:prstGeom>
           <a:solidFill>
-            <a:srgbClr val="524F4B"/>
+            <a:srgbClr val="595552"/>
           </a:solidFill>
           <a:ln>
             <a:noFill/>
@@ -3228,14 +3228,14 @@
         </p:nvSpPr>
         <p:spPr>
           <a:xfrm>
-            <a:off x="762000" y="15735300"/>
-            <a:ext cx="9525" cy="647700"/>
+            <a:off x="762000" y="15782925"/>
+            <a:ext cx="9525" cy="885825"/>
           </a:xfrm>
           <a:prstGeom prst="rect">
             <a:avLst/>
           </a:prstGeom>
           <a:solidFill>
-            <a:srgbClr val="524F4B"/>
+            <a:srgbClr val="595552"/>
           </a:solidFill>
           <a:ln>
             <a:noFill/>
@@ -3272,14 +3272,14 @@
         </p:nvSpPr>
         <p:spPr>
           <a:xfrm>
-            <a:off x="9515475" y="15735300"/>
-            <a:ext cx="9525" cy="647700"/>
+            <a:off x="9515475" y="15782925"/>
+            <a:ext cx="9525" cy="885825"/>
           </a:xfrm>
           <a:prstGeom prst="rect">
             <a:avLst/>
           </a:prstGeom>
           <a:solidFill>
-            <a:srgbClr val="524F4B"/>
+            <a:srgbClr val="595552"/>
           </a:solidFill>
           <a:ln>
             <a:noFill/>
@@ -3316,8 +3316,8 @@
         </p:nvSpPr>
         <p:spPr>
           <a:xfrm>
-            <a:off x="1024416" y="16012004"/>
-            <a:ext cx="94293" cy="94292"/>
+            <a:off x="1077621" y="16165220"/>
+            <a:ext cx="121233" cy="121234"/>
           </a:xfrm>
           <a:prstGeom prst="rect">
             <a:avLst/>
@@ -3360,8 +3360,8 @@
         </p:nvSpPr>
         <p:spPr>
           <a:xfrm>
-            <a:off x="762000" y="12096750"/>
-            <a:ext cx="14401800" cy="133350"/>
+            <a:off x="762000" y="11906250"/>
+            <a:ext cx="14401800" cy="228600"/>
           </a:xfrm>
           <a:prstGeom prst="rect">
             <a:avLst/>
@@ -3374,7 +3374,7 @@
           <a:p>
             <a:pPr algn="l"/>
             <a:r>
-              <a:rPr sz="900" i="0" b="1" spc="306">
+              <a:rPr sz="1575" i="0" b="1" spc="472">
                 <a:solidFill>
                   <a:srgbClr val="BC5B36"/>
                 </a:solidFill>
@@ -3395,8 +3395,8 @@
         </p:nvSpPr>
         <p:spPr>
           <a:xfrm>
-            <a:off x="762000" y="12363450"/>
-            <a:ext cx="14401800" cy="630882"/>
+            <a:off x="762000" y="12306300"/>
+            <a:ext cx="14401800" cy="771079"/>
           </a:xfrm>
           <a:prstGeom prst="rect">
             <a:avLst/>
@@ -3413,7 +3413,7 @@
               </a:lnSpc>
             </a:pPr>
             <a:r>
-              <a:rPr sz="5400" i="1" b="0">
+              <a:rPr sz="6600" i="1" b="0">
                 <a:solidFill>
                   <a:srgbClr val="FAF6F0"/>
                 </a:solidFill>
@@ -3434,8 +3434,8 @@
         </p:nvSpPr>
         <p:spPr>
           <a:xfrm>
-            <a:off x="762000" y="13146732"/>
-            <a:ext cx="14401800" cy="104775"/>
+            <a:off x="762000" y="13286929"/>
+            <a:ext cx="14401800" cy="190500"/>
           </a:xfrm>
           <a:prstGeom prst="rect">
             <a:avLst/>
@@ -3448,7 +3448,7 @@
           <a:p>
             <a:pPr algn="l"/>
             <a:r>
-              <a:rPr sz="750" i="0" b="0" spc="75">
+              <a:rPr sz="1275" i="0" b="0" spc="204">
                 <a:solidFill>
                   <a:srgbClr val="B7B3AE"/>
                 </a:solidFill>
@@ -3469,8 +3469,8 @@
         </p:nvSpPr>
         <p:spPr>
           <a:xfrm>
-            <a:off x="762000" y="13422957"/>
-            <a:ext cx="14401800" cy="525661"/>
+            <a:off x="762000" y="13706029"/>
+            <a:ext cx="14401800" cy="648444"/>
           </a:xfrm>
           <a:prstGeom prst="rect">
             <a:avLst/>
@@ -3487,7 +3487,7 @@
               </a:lnSpc>
             </a:pPr>
             <a:r>
-              <a:rPr sz="4500" i="0" b="1" spc="-135">
+              <a:rPr sz="5550" i="0" b="1" spc="-166">
                 <a:solidFill>
                   <a:srgbClr val="BC5B36"/>
                 </a:solidFill>
@@ -3508,8 +3508,8 @@
         </p:nvSpPr>
         <p:spPr>
           <a:xfrm>
-            <a:off x="1238250" y="15978188"/>
-            <a:ext cx="3514487" cy="161925"/>
+            <a:off x="1333500" y="16097250"/>
+            <a:ext cx="5052536" cy="257175"/>
           </a:xfrm>
           <a:prstGeom prst="rect">
             <a:avLst/>
@@ -3522,7 +3522,7 @@
           <a:p>
             <a:pPr algn="l"/>
             <a:r>
-              <a:rPr sz="1125" i="0" b="1" spc="135">
+              <a:rPr sz="1725" i="0" b="1" spc="172">
                 <a:solidFill>
                   <a:srgbClr val="FAF6F0"/>
                 </a:solidFill>
@@ -3543,8 +3543,8 @@
         </p:nvSpPr>
         <p:spPr>
           <a:xfrm>
-            <a:off x="9105900" y="15954375"/>
-            <a:ext cx="609600" cy="209550"/>
+            <a:off x="8982075" y="16078200"/>
+            <a:ext cx="716280" cy="295275"/>
           </a:xfrm>
           <a:prstGeom prst="rect">
             <a:avLst/>
@@ -3557,7 +3557,7 @@
           <a:p>
             <a:pPr algn="l"/>
             <a:r>
-              <a:rPr sz="1350" i="0" b="0">
+              <a:rPr sz="1950" i="0" b="0">
                 <a:solidFill>
                   <a:srgbClr val="BC5B36"/>
                 </a:solidFill>
@@ -3578,8 +3578,8 @@
         </p:nvSpPr>
         <p:spPr>
           <a:xfrm>
-            <a:off x="2801585" y="17297400"/>
-            <a:ext cx="4683681" cy="123825"/>
+            <a:off x="1823799" y="17192625"/>
+            <a:ext cx="6639401" cy="180975"/>
           </a:xfrm>
           <a:prstGeom prst="rect">
             <a:avLst/>
@@ -3592,9 +3592,9 @@
           <a:p>
             <a:pPr algn="ctr"/>
             <a:r>
-              <a:rPr sz="825" i="0" b="0" spc="165">
+              <a:rPr sz="1200" i="0" b="0" spc="240">
                 <a:solidFill>
-                  <a:srgbClr val="B7B3AE"/>
+                  <a:srgbClr val="BBB8B2"/>
                 </a:solidFill>
                 <a:latin typeface="Space Mono"/>
                 <a:ea typeface="Space Mono"/>
@@ -3622,7 +3622,7 @@
         <p:spPr>
           <a:xfrm>
             <a:off x="0" y="0"/>
-            <a:ext cx="10287000" cy="11525250"/>
+            <a:ext cx="10287000" cy="11239500"/>
           </a:xfrm>
           <a:prstGeom prst="rect">
             <a:avLst/>

</xml_diff>